<commit_message>
update esvee + linting
</commit_message>
<xml_diff>
--- a/docs/images/sash_workflow_overview_diagram_Vqc.pptx
+++ b/docs/images/sash_workflow_overview_diagram_Vqc.pptx
@@ -197,7 +197,7 @@
           <a:p>
             <a:fld id="{672D3BED-21AE-7948-8587-CC54A6A3C89D}" type="datetimeFigureOut">
               <a:rPr lang="en-US" smtClean="0"/>
-              <a:t>3/13/25</a:t>
+              <a:t>11/24/25</a:t>
             </a:fld>
             <a:endParaRPr lang="en-US"/>
           </a:p>
@@ -729,7 +729,7 @@
           <a:p>
             <a:fld id="{08FB1BFA-C5AE-FA47-A144-5A930C23E276}" type="datetimeFigureOut">
               <a:rPr lang="en-US" smtClean="0"/>
-              <a:t>3/13/25</a:t>
+              <a:t>11/24/25</a:t>
             </a:fld>
             <a:endParaRPr lang="en-US"/>
           </a:p>
@@ -929,7 +929,7 @@
           <a:p>
             <a:fld id="{08FB1BFA-C5AE-FA47-A144-5A930C23E276}" type="datetimeFigureOut">
               <a:rPr lang="en-US" smtClean="0"/>
-              <a:t>3/13/25</a:t>
+              <a:t>11/24/25</a:t>
             </a:fld>
             <a:endParaRPr lang="en-US"/>
           </a:p>
@@ -1139,7 +1139,7 @@
           <a:p>
             <a:fld id="{08FB1BFA-C5AE-FA47-A144-5A930C23E276}" type="datetimeFigureOut">
               <a:rPr lang="en-US" smtClean="0"/>
-              <a:t>3/13/25</a:t>
+              <a:t>11/24/25</a:t>
             </a:fld>
             <a:endParaRPr lang="en-US"/>
           </a:p>
@@ -1339,7 +1339,7 @@
           <a:p>
             <a:fld id="{08FB1BFA-C5AE-FA47-A144-5A930C23E276}" type="datetimeFigureOut">
               <a:rPr lang="en-US" smtClean="0"/>
-              <a:t>3/13/25</a:t>
+              <a:t>11/24/25</a:t>
             </a:fld>
             <a:endParaRPr lang="en-US"/>
           </a:p>
@@ -1615,7 +1615,7 @@
           <a:p>
             <a:fld id="{08FB1BFA-C5AE-FA47-A144-5A930C23E276}" type="datetimeFigureOut">
               <a:rPr lang="en-US" smtClean="0"/>
-              <a:t>3/13/25</a:t>
+              <a:t>11/24/25</a:t>
             </a:fld>
             <a:endParaRPr lang="en-US"/>
           </a:p>
@@ -1883,7 +1883,7 @@
           <a:p>
             <a:fld id="{08FB1BFA-C5AE-FA47-A144-5A930C23E276}" type="datetimeFigureOut">
               <a:rPr lang="en-US" smtClean="0"/>
-              <a:t>3/13/25</a:t>
+              <a:t>11/24/25</a:t>
             </a:fld>
             <a:endParaRPr lang="en-US"/>
           </a:p>
@@ -2298,7 +2298,7 @@
           <a:p>
             <a:fld id="{08FB1BFA-C5AE-FA47-A144-5A930C23E276}" type="datetimeFigureOut">
               <a:rPr lang="en-US" smtClean="0"/>
-              <a:t>3/13/25</a:t>
+              <a:t>11/24/25</a:t>
             </a:fld>
             <a:endParaRPr lang="en-US"/>
           </a:p>
@@ -2440,7 +2440,7 @@
           <a:p>
             <a:fld id="{08FB1BFA-C5AE-FA47-A144-5A930C23E276}" type="datetimeFigureOut">
               <a:rPr lang="en-US" smtClean="0"/>
-              <a:t>3/13/25</a:t>
+              <a:t>11/24/25</a:t>
             </a:fld>
             <a:endParaRPr lang="en-US"/>
           </a:p>
@@ -2553,7 +2553,7 @@
           <a:p>
             <a:fld id="{08FB1BFA-C5AE-FA47-A144-5A930C23E276}" type="datetimeFigureOut">
               <a:rPr lang="en-US" smtClean="0"/>
-              <a:t>3/13/25</a:t>
+              <a:t>11/24/25</a:t>
             </a:fld>
             <a:endParaRPr lang="en-US"/>
           </a:p>
@@ -2866,7 +2866,7 @@
           <a:p>
             <a:fld id="{08FB1BFA-C5AE-FA47-A144-5A930C23E276}" type="datetimeFigureOut">
               <a:rPr lang="en-US" smtClean="0"/>
-              <a:t>3/13/25</a:t>
+              <a:t>11/24/25</a:t>
             </a:fld>
             <a:endParaRPr lang="en-US"/>
           </a:p>
@@ -3155,7 +3155,7 @@
           <a:p>
             <a:fld id="{08FB1BFA-C5AE-FA47-A144-5A930C23E276}" type="datetimeFigureOut">
               <a:rPr lang="en-US" smtClean="0"/>
-              <a:t>3/13/25</a:t>
+              <a:t>11/24/25</a:t>
             </a:fld>
             <a:endParaRPr lang="en-US"/>
           </a:p>
@@ -3398,7 +3398,7 @@
           <a:p>
             <a:fld id="{08FB1BFA-C5AE-FA47-A144-5A930C23E276}" type="datetimeFigureOut">
               <a:rPr lang="en-US" smtClean="0"/>
-              <a:t>3/13/25</a:t>
+              <a:t>11/24/25</a:t>
             </a:fld>
             <a:endParaRPr lang="en-US"/>
           </a:p>
@@ -5146,7 +5146,7 @@
                     <a:sysClr val="windowText" lastClr="000000"/>
                   </a:solidFill>
                 </a:rPr>
-                <a:t>GRIDSS</a:t>
+                <a:t>ESVEE</a:t>
               </a:r>
             </a:p>
           </p:txBody>
@@ -7675,7 +7675,7 @@
                     <a:sysClr val="windowText" lastClr="000000"/>
                   </a:solidFill>
                 </a:rPr>
-                <a:t>GRIPSS:</a:t>
+                <a:t>ESVEE:</a:t>
               </a:r>
             </a:p>
             <a:p>

</xml_diff>

<commit_message>
update pipeline overview adding MutationalPatterns and HRDETECT
</commit_message>
<xml_diff>
--- a/docs/images/sash_workflow_overview_diagram_Vqc.pptx
+++ b/docs/images/sash_workflow_overview_diagram_Vqc.pptx
@@ -197,7 +197,7 @@
           <a:p>
             <a:fld id="{672D3BED-21AE-7948-8587-CC54A6A3C89D}" type="datetimeFigureOut">
               <a:rPr lang="en-US" smtClean="0"/>
-              <a:t>11/24/25</a:t>
+              <a:t>12/23/25</a:t>
             </a:fld>
             <a:endParaRPr lang="en-US"/>
           </a:p>
@@ -729,7 +729,7 @@
           <a:p>
             <a:fld id="{08FB1BFA-C5AE-FA47-A144-5A930C23E276}" type="datetimeFigureOut">
               <a:rPr lang="en-US" smtClean="0"/>
-              <a:t>11/24/25</a:t>
+              <a:t>12/23/25</a:t>
             </a:fld>
             <a:endParaRPr lang="en-US"/>
           </a:p>
@@ -929,7 +929,7 @@
           <a:p>
             <a:fld id="{08FB1BFA-C5AE-FA47-A144-5A930C23E276}" type="datetimeFigureOut">
               <a:rPr lang="en-US" smtClean="0"/>
-              <a:t>11/24/25</a:t>
+              <a:t>12/23/25</a:t>
             </a:fld>
             <a:endParaRPr lang="en-US"/>
           </a:p>
@@ -1139,7 +1139,7 @@
           <a:p>
             <a:fld id="{08FB1BFA-C5AE-FA47-A144-5A930C23E276}" type="datetimeFigureOut">
               <a:rPr lang="en-US" smtClean="0"/>
-              <a:t>11/24/25</a:t>
+              <a:t>12/23/25</a:t>
             </a:fld>
             <a:endParaRPr lang="en-US"/>
           </a:p>
@@ -1339,7 +1339,7 @@
           <a:p>
             <a:fld id="{08FB1BFA-C5AE-FA47-A144-5A930C23E276}" type="datetimeFigureOut">
               <a:rPr lang="en-US" smtClean="0"/>
-              <a:t>11/24/25</a:t>
+              <a:t>12/23/25</a:t>
             </a:fld>
             <a:endParaRPr lang="en-US"/>
           </a:p>
@@ -1615,7 +1615,7 @@
           <a:p>
             <a:fld id="{08FB1BFA-C5AE-FA47-A144-5A930C23E276}" type="datetimeFigureOut">
               <a:rPr lang="en-US" smtClean="0"/>
-              <a:t>11/24/25</a:t>
+              <a:t>12/23/25</a:t>
             </a:fld>
             <a:endParaRPr lang="en-US"/>
           </a:p>
@@ -1883,7 +1883,7 @@
           <a:p>
             <a:fld id="{08FB1BFA-C5AE-FA47-A144-5A930C23E276}" type="datetimeFigureOut">
               <a:rPr lang="en-US" smtClean="0"/>
-              <a:t>11/24/25</a:t>
+              <a:t>12/23/25</a:t>
             </a:fld>
             <a:endParaRPr lang="en-US"/>
           </a:p>
@@ -2298,7 +2298,7 @@
           <a:p>
             <a:fld id="{08FB1BFA-C5AE-FA47-A144-5A930C23E276}" type="datetimeFigureOut">
               <a:rPr lang="en-US" smtClean="0"/>
-              <a:t>11/24/25</a:t>
+              <a:t>12/23/25</a:t>
             </a:fld>
             <a:endParaRPr lang="en-US"/>
           </a:p>
@@ -2440,7 +2440,7 @@
           <a:p>
             <a:fld id="{08FB1BFA-C5AE-FA47-A144-5A930C23E276}" type="datetimeFigureOut">
               <a:rPr lang="en-US" smtClean="0"/>
-              <a:t>11/24/25</a:t>
+              <a:t>12/23/25</a:t>
             </a:fld>
             <a:endParaRPr lang="en-US"/>
           </a:p>
@@ -2553,7 +2553,7 @@
           <a:p>
             <a:fld id="{08FB1BFA-C5AE-FA47-A144-5A930C23E276}" type="datetimeFigureOut">
               <a:rPr lang="en-US" smtClean="0"/>
-              <a:t>11/24/25</a:t>
+              <a:t>12/23/25</a:t>
             </a:fld>
             <a:endParaRPr lang="en-US"/>
           </a:p>
@@ -2866,7 +2866,7 @@
           <a:p>
             <a:fld id="{08FB1BFA-C5AE-FA47-A144-5A930C23E276}" type="datetimeFigureOut">
               <a:rPr lang="en-US" smtClean="0"/>
-              <a:t>11/24/25</a:t>
+              <a:t>12/23/25</a:t>
             </a:fld>
             <a:endParaRPr lang="en-US"/>
           </a:p>
@@ -3155,7 +3155,7 @@
           <a:p>
             <a:fld id="{08FB1BFA-C5AE-FA47-A144-5A930C23E276}" type="datetimeFigureOut">
               <a:rPr lang="en-US" smtClean="0"/>
-              <a:t>11/24/25</a:t>
+              <a:t>12/23/25</a:t>
             </a:fld>
             <a:endParaRPr lang="en-US"/>
           </a:p>
@@ -3398,7 +3398,7 @@
           <a:p>
             <a:fld id="{08FB1BFA-C5AE-FA47-A144-5A930C23E276}" type="datetimeFigureOut">
               <a:rPr lang="en-US" smtClean="0"/>
-              <a:t>11/24/25</a:t>
+              <a:t>12/23/25</a:t>
             </a:fld>
             <a:endParaRPr lang="en-US"/>
           </a:p>
@@ -3821,6 +3821,54 @@
           <a:chExt cx="0" cy="0"/>
         </a:xfrm>
       </p:grpSpPr>
+      <p:cxnSp>
+        <p:nvCxnSpPr>
+          <p:cNvPr id="526" name="Straight Arrow Connector 525">
+            <a:extLst>
+              <a:ext uri="{FF2B5EF4-FFF2-40B4-BE49-F238E27FC236}">
+                <a16:creationId xmlns:a16="http://schemas.microsoft.com/office/drawing/2014/main" id="{59BAB151-31DF-A021-FBAF-981C56C3F262}"/>
+              </a:ext>
+            </a:extLst>
+          </p:cNvPr>
+          <p:cNvCxnSpPr>
+            <a:cxnSpLocks/>
+            <a:endCxn id="14" idx="1"/>
+          </p:cNvCxnSpPr>
+          <p:nvPr/>
+        </p:nvCxnSpPr>
+        <p:spPr>
+          <a:xfrm flipV="1">
+            <a:off x="7712435" y="2470001"/>
+            <a:ext cx="99536" cy="4053"/>
+          </a:xfrm>
+          <a:prstGeom prst="straightConnector1">
+            <a:avLst/>
+          </a:prstGeom>
+          <a:ln>
+            <a:solidFill>
+              <a:schemeClr val="tx1">
+                <a:lumMod val="85000"/>
+                <a:lumOff val="15000"/>
+              </a:schemeClr>
+            </a:solidFill>
+            <a:tailEnd type="triangle"/>
+          </a:ln>
+        </p:spPr>
+        <p:style>
+          <a:lnRef idx="1">
+            <a:schemeClr val="accent1"/>
+          </a:lnRef>
+          <a:fillRef idx="0">
+            <a:schemeClr val="accent1"/>
+          </a:fillRef>
+          <a:effectRef idx="0">
+            <a:schemeClr val="accent1"/>
+          </a:effectRef>
+          <a:fontRef idx="minor">
+            <a:schemeClr val="tx1"/>
+          </a:fontRef>
+        </p:style>
+      </p:cxnSp>
       <p:grpSp>
         <p:nvGrpSpPr>
           <p:cNvPr id="506" name="Group 505">
@@ -3835,10 +3883,10 @@
         </p:nvGrpSpPr>
         <p:grpSpPr>
           <a:xfrm>
-            <a:off x="157383" y="385792"/>
-            <a:ext cx="12034617" cy="6472208"/>
-            <a:chOff x="-83342" y="329884"/>
-            <a:chExt cx="12034617" cy="6472208"/>
+            <a:off x="255705" y="406832"/>
+            <a:ext cx="12034617" cy="6463540"/>
+            <a:chOff x="-83342" y="247369"/>
+            <a:chExt cx="12034617" cy="6463540"/>
           </a:xfrm>
         </p:grpSpPr>
         <p:sp>
@@ -3964,7 +4012,7 @@
           <p:spPr>
             <a:xfrm>
               <a:off x="5307912" y="5095210"/>
-              <a:ext cx="3753951" cy="1706882"/>
+              <a:ext cx="3740109" cy="1603327"/>
             </a:xfrm>
             <a:prstGeom prst="rect">
               <a:avLst/>
@@ -4051,7 +4099,7 @@
             <a:lstStyle/>
             <a:p>
               <a:pPr algn="ctr"/>
-              <a:endParaRPr lang="en-US"/>
+              <a:endParaRPr lang="en-US" dirty="0"/>
             </a:p>
           </p:txBody>
         </p:sp>
@@ -4468,8 +4516,8 @@
           </p:nvSpPr>
           <p:spPr>
             <a:xfrm>
-              <a:off x="2284554" y="1567352"/>
-              <a:ext cx="9666721" cy="3463160"/>
+              <a:off x="2284554" y="1567351"/>
+              <a:ext cx="9666721" cy="3492343"/>
             </a:xfrm>
             <a:prstGeom prst="rect">
               <a:avLst/>
@@ -4523,7 +4571,7 @@
           <p:spPr>
             <a:xfrm>
               <a:off x="9538540" y="1617113"/>
-              <a:ext cx="2321661" cy="3357767"/>
+              <a:ext cx="2321661" cy="3386062"/>
             </a:xfrm>
             <a:prstGeom prst="rect">
               <a:avLst/>
@@ -4576,8 +4624,8 @@
           </p:nvSpPr>
           <p:spPr>
             <a:xfrm>
-              <a:off x="3524596" y="428434"/>
-              <a:ext cx="8171411" cy="601609"/>
+              <a:off x="3524596" y="257226"/>
+              <a:ext cx="8197177" cy="772817"/>
             </a:xfrm>
             <a:prstGeom prst="rect">
               <a:avLst/>
@@ -4614,7 +4662,7 @@
             <a:lstStyle/>
             <a:p>
               <a:pPr algn="ctr"/>
-              <a:endParaRPr lang="en-US"/>
+              <a:endParaRPr lang="en-US" dirty="0"/>
             </a:p>
           </p:txBody>
         </p:sp>
@@ -4632,8 +4680,8 @@
           </p:nvSpPr>
           <p:spPr>
             <a:xfrm>
-              <a:off x="-11223" y="1563940"/>
-              <a:ext cx="2258806" cy="3463160"/>
+              <a:off x="-11223" y="1563939"/>
+              <a:ext cx="2258806" cy="3492343"/>
             </a:xfrm>
             <a:prstGeom prst="rect">
               <a:avLst/>
@@ -4976,7 +5024,7 @@
           </p:nvSpPr>
           <p:spPr>
             <a:xfrm>
-              <a:off x="7472924" y="663118"/>
+              <a:off x="7484499" y="651543"/>
               <a:ext cx="1011397" cy="206192"/>
             </a:xfrm>
             <a:prstGeom prst="roundRect">
@@ -5039,7 +5087,7 @@
           </p:nvSpPr>
           <p:spPr>
             <a:xfrm>
-              <a:off x="4737853" y="661949"/>
+              <a:off x="3742430" y="645901"/>
               <a:ext cx="1011397" cy="206192"/>
             </a:xfrm>
             <a:prstGeom prst="roundRect">
@@ -5102,7 +5150,7 @@
           </p:nvSpPr>
           <p:spPr>
             <a:xfrm>
-              <a:off x="6045535" y="661949"/>
+              <a:off x="5091432" y="645901"/>
               <a:ext cx="1011397" cy="206192"/>
             </a:xfrm>
             <a:prstGeom prst="roundRect">
@@ -5458,8 +5506,8 @@
           </p:nvSpPr>
           <p:spPr>
             <a:xfrm>
-              <a:off x="4607575" y="574350"/>
-              <a:ext cx="6927717" cy="370247"/>
+              <a:off x="3612205" y="504902"/>
+              <a:ext cx="7878075" cy="444970"/>
             </a:xfrm>
             <a:prstGeom prst="roundRect">
               <a:avLst>
@@ -5517,7 +5565,7 @@
           </p:nvSpPr>
           <p:spPr>
             <a:xfrm>
-              <a:off x="3447672" y="633580"/>
+              <a:off x="6794285" y="247369"/>
               <a:ext cx="1111906" cy="276999"/>
             </a:xfrm>
             <a:prstGeom prst="rect">
@@ -6058,8 +6106,8 @@
           </p:nvCxnSpPr>
           <p:spPr>
             <a:xfrm>
-              <a:off x="7296566" y="1840732"/>
-              <a:ext cx="682057" cy="366710"/>
+              <a:off x="7296566" y="1830900"/>
+              <a:ext cx="682057" cy="376542"/>
             </a:xfrm>
             <a:prstGeom prst="bentConnector2">
               <a:avLst/>
@@ -6336,57 +6384,6 @@
         </p:cxnSp>
         <p:cxnSp>
           <p:nvCxnSpPr>
-            <p:cNvPr id="41" name="Elbow Connector 40">
-              <a:extLst>
-                <a:ext uri="{FF2B5EF4-FFF2-40B4-BE49-F238E27FC236}">
-                  <a16:creationId xmlns:a16="http://schemas.microsoft.com/office/drawing/2014/main" id="{5BE8AFD8-AC27-9170-B2C0-E313D32CB7FF}"/>
-                </a:ext>
-              </a:extLst>
-            </p:cNvPr>
-            <p:cNvCxnSpPr>
-              <a:cxnSpLocks/>
-              <a:stCxn id="4" idx="2"/>
-              <a:endCxn id="14" idx="0"/>
-            </p:cNvCxnSpPr>
-            <p:nvPr/>
-          </p:nvCxnSpPr>
-          <p:spPr>
-            <a:xfrm rot="5400000">
-              <a:off x="7986672" y="860092"/>
-              <a:ext cx="1339301" cy="1355398"/>
-            </a:xfrm>
-            <a:prstGeom prst="bentConnector3">
-              <a:avLst>
-                <a:gd name="adj1" fmla="val 72965"/>
-              </a:avLst>
-            </a:prstGeom>
-            <a:ln>
-              <a:solidFill>
-                <a:schemeClr val="tx1">
-                  <a:lumMod val="85000"/>
-                  <a:lumOff val="15000"/>
-                </a:schemeClr>
-              </a:solidFill>
-              <a:tailEnd type="triangle"/>
-            </a:ln>
-          </p:spPr>
-          <p:style>
-            <a:lnRef idx="1">
-              <a:schemeClr val="accent1"/>
-            </a:lnRef>
-            <a:fillRef idx="0">
-              <a:schemeClr val="accent1"/>
-            </a:fillRef>
-            <a:effectRef idx="0">
-              <a:schemeClr val="accent1"/>
-            </a:effectRef>
-            <a:fontRef idx="minor">
-              <a:schemeClr val="tx1"/>
-            </a:fontRef>
-          </p:style>
-        </p:cxnSp>
-        <p:cxnSp>
-          <p:nvCxnSpPr>
             <p:cNvPr id="52" name="Straight Arrow Connector 51">
               <a:extLst>
                 <a:ext uri="{FF2B5EF4-FFF2-40B4-BE49-F238E27FC236}">
@@ -6550,12 +6547,12 @@
           </p:nvCxnSpPr>
           <p:spPr>
             <a:xfrm rot="5400000">
-              <a:off x="3568014" y="443873"/>
-              <a:ext cx="1251270" cy="2099806"/>
+              <a:off x="3062279" y="933561"/>
+              <a:ext cx="1267318" cy="1104383"/>
             </a:xfrm>
             <a:prstGeom prst="bentConnector3">
               <a:avLst>
-                <a:gd name="adj1" fmla="val 57972"/>
+                <a:gd name="adj1" fmla="val 50000"/>
               </a:avLst>
             </a:prstGeom>
             <a:ln>
@@ -6600,9 +6597,9 @@
             <p:nvPr/>
           </p:nvCxnSpPr>
           <p:spPr>
-            <a:xfrm>
-              <a:off x="7978623" y="869310"/>
-              <a:ext cx="0" cy="1338132"/>
+            <a:xfrm flipH="1">
+              <a:off x="7978623" y="857735"/>
+              <a:ext cx="11575" cy="1349707"/>
             </a:xfrm>
             <a:prstGeom prst="straightConnector1">
               <a:avLst/>
@@ -6731,7 +6728,7 @@
           </p:nvSpPr>
           <p:spPr>
             <a:xfrm>
-              <a:off x="10122414" y="2883564"/>
+              <a:off x="10110839" y="2883564"/>
               <a:ext cx="1395243" cy="410596"/>
             </a:xfrm>
             <a:prstGeom prst="roundRect">
@@ -7216,9 +7213,9 @@
             <p:nvPr/>
           </p:nvCxnSpPr>
           <p:spPr>
-            <a:xfrm flipH="1">
-              <a:off x="10811901" y="3294160"/>
-              <a:ext cx="8135" cy="224936"/>
+            <a:xfrm>
+              <a:off x="10808461" y="3294160"/>
+              <a:ext cx="3440" cy="224936"/>
             </a:xfrm>
             <a:prstGeom prst="straightConnector1">
               <a:avLst/>
@@ -7364,11 +7361,11 @@
           <p:spPr>
             <a:xfrm flipH="1">
               <a:off x="11279477" y="3088862"/>
-              <a:ext cx="238180" cy="1476548"/>
+              <a:ext cx="226605" cy="1476548"/>
             </a:xfrm>
             <a:prstGeom prst="bentConnector3">
               <a:avLst>
-                <a:gd name="adj1" fmla="val -95978"/>
+                <a:gd name="adj1" fmla="val -100880"/>
               </a:avLst>
             </a:prstGeom>
             <a:ln>
@@ -7452,7 +7449,7 @@
           </p:nvSpPr>
           <p:spPr>
             <a:xfrm>
-              <a:off x="5856302" y="1646893"/>
+              <a:off x="5856302" y="1607565"/>
               <a:ext cx="1475808" cy="419787"/>
             </a:xfrm>
             <a:prstGeom prst="rect">
@@ -7631,7 +7628,7 @@
           </p:nvSpPr>
           <p:spPr>
             <a:xfrm>
-              <a:off x="5907160" y="1686490"/>
+              <a:off x="5907160" y="1676658"/>
               <a:ext cx="1389406" cy="308483"/>
             </a:xfrm>
             <a:prstGeom prst="roundRect">
@@ -8021,7 +8018,7 @@
         </p:nvSpPr>
         <p:spPr>
           <a:xfrm>
-            <a:off x="10564950" y="2495938"/>
+            <a:off x="10592728" y="2575116"/>
             <a:ext cx="1011397" cy="301656"/>
           </a:xfrm>
           <a:prstGeom prst="roundRect">
@@ -8060,18 +8057,13 @@
           <a:p>
             <a:pPr algn="ctr"/>
             <a:r>
-              <a:rPr lang="en-US" sz="1050" dirty="0" err="1">
+              <a:rPr lang="en-US" sz="1050" dirty="0">
                 <a:solidFill>
                   <a:sysClr val="windowText" lastClr="000000"/>
                 </a:solidFill>
               </a:rPr>
-              <a:t>bolt:PURPLE</a:t>
+              <a:t>PURPLE</a:t>
             </a:r>
-            <a:endParaRPr lang="en-US" sz="1050" dirty="0">
-              <a:solidFill>
-                <a:sysClr val="windowText" lastClr="000000"/>
-              </a:solidFill>
-            </a:endParaRPr>
           </a:p>
           <a:p>
             <a:pPr algn="ctr"/>
@@ -8086,54 +8078,6 @@
           </a:p>
         </p:txBody>
       </p:sp>
-      <p:cxnSp>
-        <p:nvCxnSpPr>
-          <p:cNvPr id="526" name="Straight Arrow Connector 525">
-            <a:extLst>
-              <a:ext uri="{FF2B5EF4-FFF2-40B4-BE49-F238E27FC236}">
-                <a16:creationId xmlns:a16="http://schemas.microsoft.com/office/drawing/2014/main" id="{59BAB151-31DF-A021-FBAF-981C56C3F262}"/>
-              </a:ext>
-            </a:extLst>
-          </p:cNvPr>
-          <p:cNvCxnSpPr>
-            <a:cxnSpLocks/>
-            <a:endCxn id="14" idx="1"/>
-          </p:cNvCxnSpPr>
-          <p:nvPr/>
-        </p:nvCxnSpPr>
-        <p:spPr>
-          <a:xfrm flipV="1">
-            <a:off x="7614113" y="2366446"/>
-            <a:ext cx="99536" cy="4053"/>
-          </a:xfrm>
-          <a:prstGeom prst="straightConnector1">
-            <a:avLst/>
-          </a:prstGeom>
-          <a:ln>
-            <a:solidFill>
-              <a:schemeClr val="tx1">
-                <a:lumMod val="85000"/>
-                <a:lumOff val="15000"/>
-              </a:schemeClr>
-            </a:solidFill>
-            <a:tailEnd type="triangle"/>
-          </a:ln>
-        </p:spPr>
-        <p:style>
-          <a:lnRef idx="1">
-            <a:schemeClr val="accent1"/>
-          </a:lnRef>
-          <a:fillRef idx="0">
-            <a:schemeClr val="accent1"/>
-          </a:fillRef>
-          <a:effectRef idx="0">
-            <a:schemeClr val="accent1"/>
-          </a:effectRef>
-          <a:fontRef idx="minor">
-            <a:schemeClr val="tx1"/>
-          </a:fontRef>
-        </p:style>
-      </p:cxnSp>
       <p:cxnSp>
         <p:nvCxnSpPr>
           <p:cNvPr id="530" name="Straight Arrow Connector 529">
@@ -8145,63 +8089,14 @@
           </p:cNvPr>
           <p:cNvCxnSpPr>
             <a:cxnSpLocks/>
-            <a:stCxn id="507" idx="2"/>
             <a:endCxn id="124" idx="0"/>
           </p:cNvCxnSpPr>
           <p:nvPr/>
         </p:nvCxnSpPr>
         <p:spPr>
-          <a:xfrm flipH="1">
-            <a:off x="11060761" y="2797594"/>
-            <a:ext cx="9888" cy="141878"/>
-          </a:xfrm>
-          <a:prstGeom prst="straightConnector1">
-            <a:avLst/>
-          </a:prstGeom>
-          <a:ln>
-            <a:solidFill>
-              <a:schemeClr val="tx1">
-                <a:lumMod val="85000"/>
-                <a:lumOff val="15000"/>
-              </a:schemeClr>
-            </a:solidFill>
-            <a:tailEnd type="triangle"/>
-          </a:ln>
-        </p:spPr>
-        <p:style>
-          <a:lnRef idx="1">
-            <a:schemeClr val="accent1"/>
-          </a:lnRef>
-          <a:fillRef idx="0">
-            <a:schemeClr val="accent1"/>
-          </a:fillRef>
-          <a:effectRef idx="0">
-            <a:schemeClr val="accent1"/>
-          </a:effectRef>
-          <a:fontRef idx="minor">
-            <a:schemeClr val="tx1"/>
-          </a:fontRef>
-        </p:style>
-      </p:cxnSp>
-      <p:cxnSp>
-        <p:nvCxnSpPr>
-          <p:cNvPr id="538" name="Straight Arrow Connector 537">
-            <a:extLst>
-              <a:ext uri="{FF2B5EF4-FFF2-40B4-BE49-F238E27FC236}">
-                <a16:creationId xmlns:a16="http://schemas.microsoft.com/office/drawing/2014/main" id="{203595FE-D532-6B6E-D9CB-CDD974225461}"/>
-              </a:ext>
-            </a:extLst>
-          </p:cNvPr>
-          <p:cNvCxnSpPr>
-            <a:cxnSpLocks/>
-            <a:endCxn id="15" idx="0"/>
-          </p:cNvCxnSpPr>
-          <p:nvPr/>
-        </p:nvCxnSpPr>
-        <p:spPr>
-          <a:xfrm flipH="1">
-            <a:off x="6842588" y="917833"/>
-            <a:ext cx="7930" cy="824565"/>
+          <a:xfrm>
+            <a:off x="11147508" y="2876772"/>
+            <a:ext cx="0" cy="166255"/>
           </a:xfrm>
           <a:prstGeom prst="straightConnector1">
             <a:avLst/>
@@ -8248,13 +8143,292 @@
         </p:nvCxnSpPr>
         <p:spPr>
           <a:xfrm flipV="1">
-            <a:off x="5837856" y="3813867"/>
+            <a:off x="5936178" y="3917422"/>
             <a:ext cx="4656550" cy="444969"/>
           </a:xfrm>
           <a:prstGeom prst="bentConnector3">
             <a:avLst>
               <a:gd name="adj1" fmla="val 11507"/>
             </a:avLst>
+          </a:prstGeom>
+          <a:ln>
+            <a:solidFill>
+              <a:schemeClr val="tx1">
+                <a:lumMod val="85000"/>
+                <a:lumOff val="15000"/>
+              </a:schemeClr>
+            </a:solidFill>
+            <a:tailEnd type="none"/>
+          </a:ln>
+        </p:spPr>
+        <p:style>
+          <a:lnRef idx="1">
+            <a:schemeClr val="accent1"/>
+          </a:lnRef>
+          <a:fillRef idx="0">
+            <a:schemeClr val="accent1"/>
+          </a:fillRef>
+          <a:effectRef idx="0">
+            <a:schemeClr val="accent1"/>
+          </a:effectRef>
+          <a:fontRef idx="minor">
+            <a:schemeClr val="tx1"/>
+          </a:fontRef>
+        </p:style>
+      </p:cxnSp>
+      <p:sp>
+        <p:nvSpPr>
+          <p:cNvPr id="32" name="Rounded Rectangle 31">
+            <a:extLst>
+              <a:ext uri="{FF2B5EF4-FFF2-40B4-BE49-F238E27FC236}">
+                <a16:creationId xmlns:a16="http://schemas.microsoft.com/office/drawing/2014/main" id="{B1BA7EE3-B78A-A701-1E68-D1228A4606C0}"/>
+              </a:ext>
+            </a:extLst>
+          </p:cNvPr>
+          <p:cNvSpPr/>
+          <p:nvPr/>
+        </p:nvSpPr>
+        <p:spPr>
+          <a:xfrm>
+            <a:off x="8938737" y="2305191"/>
+            <a:ext cx="834528" cy="301657"/>
+          </a:xfrm>
+          <a:prstGeom prst="roundRect">
+            <a:avLst>
+              <a:gd name="adj" fmla="val 6667"/>
+            </a:avLst>
+          </a:prstGeom>
+          <a:solidFill>
+            <a:schemeClr val="bg1"/>
+          </a:solidFill>
+          <a:ln>
+            <a:solidFill>
+              <a:schemeClr val="tx1"/>
+            </a:solidFill>
+          </a:ln>
+        </p:spPr>
+        <p:style>
+          <a:lnRef idx="2">
+            <a:schemeClr val="accent1">
+              <a:shade val="50000"/>
+            </a:schemeClr>
+          </a:lnRef>
+          <a:fillRef idx="1">
+            <a:schemeClr val="accent1"/>
+          </a:fillRef>
+          <a:effectRef idx="0">
+            <a:schemeClr val="accent1"/>
+          </a:effectRef>
+          <a:fontRef idx="minor">
+            <a:schemeClr val="lt1"/>
+          </a:fontRef>
+        </p:style>
+        <p:txBody>
+          <a:bodyPr rtlCol="0" anchor="ctr"/>
+          <a:lstStyle/>
+          <a:p>
+            <a:pPr algn="ctr"/>
+            <a:r>
+              <a:rPr lang="en-US" sz="1050" dirty="0" err="1">
+                <a:solidFill>
+                  <a:sysClr val="windowText" lastClr="000000"/>
+                </a:solidFill>
+              </a:rPr>
+              <a:t>MutationalPatterns</a:t>
+            </a:r>
+            <a:r>
+              <a:rPr lang="en-US" sz="1050" dirty="0">
+                <a:solidFill>
+                  <a:sysClr val="windowText" lastClr="000000"/>
+                </a:solidFill>
+              </a:rPr>
+              <a:t> </a:t>
+            </a:r>
+          </a:p>
+        </p:txBody>
+      </p:sp>
+      <p:sp>
+        <p:nvSpPr>
+          <p:cNvPr id="46" name="Rounded Rectangle 45">
+            <a:extLst>
+              <a:ext uri="{FF2B5EF4-FFF2-40B4-BE49-F238E27FC236}">
+                <a16:creationId xmlns:a16="http://schemas.microsoft.com/office/drawing/2014/main" id="{984126AF-1E42-ED82-967D-C78DCDB12CF2}"/>
+              </a:ext>
+            </a:extLst>
+          </p:cNvPr>
+          <p:cNvSpPr/>
+          <p:nvPr/>
+        </p:nvSpPr>
+        <p:spPr>
+          <a:xfrm>
+            <a:off x="6677888" y="820441"/>
+            <a:ext cx="1011397" cy="206192"/>
+          </a:xfrm>
+          <a:prstGeom prst="roundRect">
+            <a:avLst>
+              <a:gd name="adj" fmla="val 6667"/>
+            </a:avLst>
+          </a:prstGeom>
+          <a:solidFill>
+            <a:schemeClr val="bg1"/>
+          </a:solidFill>
+          <a:ln>
+            <a:solidFill>
+              <a:schemeClr val="tx1"/>
+            </a:solidFill>
+          </a:ln>
+        </p:spPr>
+        <p:style>
+          <a:lnRef idx="2">
+            <a:schemeClr val="accent1">
+              <a:shade val="50000"/>
+            </a:schemeClr>
+          </a:lnRef>
+          <a:fillRef idx="1">
+            <a:schemeClr val="accent1"/>
+          </a:fillRef>
+          <a:effectRef idx="0">
+            <a:schemeClr val="accent1"/>
+          </a:effectRef>
+          <a:fontRef idx="minor">
+            <a:schemeClr val="lt1"/>
+          </a:fontRef>
+        </p:style>
+        <p:txBody>
+          <a:bodyPr rtlCol="0" anchor="ctr"/>
+          <a:lstStyle/>
+          <a:p>
+            <a:pPr algn="ctr"/>
+            <a:r>
+              <a:rPr lang="en-US" sz="1050" dirty="0">
+                <a:solidFill>
+                  <a:sysClr val="windowText" lastClr="000000"/>
+                </a:solidFill>
+              </a:rPr>
+              <a:t>HRDETECT</a:t>
+            </a:r>
+          </a:p>
+        </p:txBody>
+      </p:sp>
+      <p:cxnSp>
+        <p:nvCxnSpPr>
+          <p:cNvPr id="50" name="Elbow Connector 49">
+            <a:extLst>
+              <a:ext uri="{FF2B5EF4-FFF2-40B4-BE49-F238E27FC236}">
+                <a16:creationId xmlns:a16="http://schemas.microsoft.com/office/drawing/2014/main" id="{AAABCE0E-BFA2-3A22-8D05-EEDD6644A560}"/>
+              </a:ext>
+            </a:extLst>
+          </p:cNvPr>
+          <p:cNvCxnSpPr>
+            <a:cxnSpLocks/>
+            <a:endCxn id="382" idx="1"/>
+          </p:cNvCxnSpPr>
+          <p:nvPr/>
+        </p:nvCxnSpPr>
+        <p:spPr>
+          <a:xfrm rot="16200000" flipH="1">
+            <a:off x="5553523" y="1335096"/>
+            <a:ext cx="939050" cy="344602"/>
+          </a:xfrm>
+          <a:prstGeom prst="bentConnector2">
+            <a:avLst/>
+          </a:prstGeom>
+          <a:ln>
+            <a:solidFill>
+              <a:schemeClr val="tx1">
+                <a:lumMod val="85000"/>
+                <a:lumOff val="15000"/>
+              </a:schemeClr>
+            </a:solidFill>
+            <a:tailEnd type="triangle"/>
+          </a:ln>
+        </p:spPr>
+        <p:style>
+          <a:lnRef idx="1">
+            <a:schemeClr val="accent1"/>
+          </a:lnRef>
+          <a:fillRef idx="0">
+            <a:schemeClr val="accent1"/>
+          </a:fillRef>
+          <a:effectRef idx="0">
+            <a:schemeClr val="accent1"/>
+          </a:effectRef>
+          <a:fontRef idx="minor">
+            <a:schemeClr val="tx1"/>
+          </a:fontRef>
+        </p:style>
+      </p:cxnSp>
+      <p:cxnSp>
+        <p:nvCxnSpPr>
+          <p:cNvPr id="450" name="Elbow Connector 449">
+            <a:extLst>
+              <a:ext uri="{FF2B5EF4-FFF2-40B4-BE49-F238E27FC236}">
+                <a16:creationId xmlns:a16="http://schemas.microsoft.com/office/drawing/2014/main" id="{C3F3FB6B-6412-7CB7-7A50-C366263E1B68}"/>
+              </a:ext>
+            </a:extLst>
+          </p:cNvPr>
+          <p:cNvCxnSpPr>
+            <a:cxnSpLocks/>
+          </p:cNvCxnSpPr>
+          <p:nvPr/>
+        </p:nvCxnSpPr>
+        <p:spPr>
+          <a:xfrm rot="10800000" flipV="1">
+            <a:off x="8264454" y="1037869"/>
+            <a:ext cx="1388835" cy="469527"/>
+          </a:xfrm>
+          <a:prstGeom prst="bentConnector3">
+            <a:avLst>
+              <a:gd name="adj1" fmla="val -1671"/>
+            </a:avLst>
+          </a:prstGeom>
+          <a:ln>
+            <a:solidFill>
+              <a:schemeClr val="tx1">
+                <a:lumMod val="85000"/>
+                <a:lumOff val="15000"/>
+              </a:schemeClr>
+            </a:solidFill>
+            <a:tailEnd type="none"/>
+          </a:ln>
+        </p:spPr>
+        <p:style>
+          <a:lnRef idx="1">
+            <a:schemeClr val="accent1"/>
+          </a:lnRef>
+          <a:fillRef idx="0">
+            <a:schemeClr val="accent1"/>
+          </a:fillRef>
+          <a:effectRef idx="0">
+            <a:schemeClr val="accent1"/>
+          </a:effectRef>
+          <a:fontRef idx="minor">
+            <a:schemeClr val="tx1"/>
+          </a:fontRef>
+        </p:style>
+      </p:cxnSp>
+      <p:cxnSp>
+        <p:nvCxnSpPr>
+          <p:cNvPr id="468" name="Elbow Connector 467">
+            <a:extLst>
+              <a:ext uri="{FF2B5EF4-FFF2-40B4-BE49-F238E27FC236}">
+                <a16:creationId xmlns:a16="http://schemas.microsoft.com/office/drawing/2014/main" id="{C8222B83-928F-702D-7D26-F92C7CB70415}"/>
+              </a:ext>
+            </a:extLst>
+          </p:cNvPr>
+          <p:cNvCxnSpPr>
+            <a:cxnSpLocks/>
+            <a:stCxn id="46" idx="2"/>
+          </p:cNvCxnSpPr>
+          <p:nvPr/>
+        </p:nvCxnSpPr>
+        <p:spPr>
+          <a:xfrm rot="16200000" flipH="1">
+            <a:off x="7483638" y="726582"/>
+            <a:ext cx="480764" cy="1080866"/>
+          </a:xfrm>
+          <a:prstGeom prst="bentConnector2">
+            <a:avLst/>
           </a:prstGeom>
           <a:ln>
             <a:solidFill>

</xml_diff>